<commit_message>
version2 of electtric field part presentation
</commit_message>
<xml_diff>
--- a/presentation/yaoqi-electric-field-part-presentation.pptx
+++ b/presentation/yaoqi-electric-field-part-presentation.pptx
@@ -5,7 +5,7 @@
     <p:sldMasterId id="2147483795" r:id="rId1"/>
   </p:sldMasterIdLst>
   <p:notesMasterIdLst>
-    <p:notesMasterId r:id="rId10"/>
+    <p:notesMasterId r:id="rId12"/>
   </p:notesMasterIdLst>
   <p:sldIdLst>
     <p:sldId id="256" r:id="rId2"/>
@@ -16,6 +16,8 @@
     <p:sldId id="302" r:id="rId7"/>
     <p:sldId id="301" r:id="rId8"/>
     <p:sldId id="300" r:id="rId9"/>
+    <p:sldId id="306" r:id="rId10"/>
+    <p:sldId id="307" r:id="rId11"/>
   </p:sldIdLst>
   <p:sldSz cx="9144000" cy="5143500" type="screen16x9"/>
   <p:notesSz cx="6858000" cy="9144000"/>
@@ -204,7 +206,7 @@
           <a:p>
             <a:fld id="{C9BEE1CD-6EDF-5C43-ACE9-942F6C137C3E}" type="datetimeFigureOut">
               <a:rPr lang="en-US" smtClean="0"/>
-              <a:t>5/31/2026</a:t>
+              <a:t>5/31/26</a:t>
             </a:fld>
             <a:endParaRPr lang="en-US"/>
           </a:p>
@@ -622,7 +624,7 @@
             </a:pPr>
             <a:r>
               <a:rPr lang="en-GB"/>
-              <a:t>The message is causality plus transverse projection: current acceleration at retarded time is the source of the far field.</a:t>
+              <a:t>The message is causality plus transverse projection: current acceleration at retarded time is the source of the far field. Also note: a steady current does not radiate, so the emitted field follows dJ/dt.</a:t>
             </a:r>
             <a:endParaRPr lang="en-GB" dirty="0"/>
           </a:p>
@@ -727,7 +729,7 @@
             </a:pPr>
             <a:r>
               <a:rPr lang="en-GB"/>
-              <a:t>Use this slide to connect every mathematical symbol to an actual array operation in the MATLAB code.</a:t>
+              <a:t>Use this slide to connect every mathematical symbol to an actual array operation in the MATLAB code. Mention that complexity is O(Nx Ny Nt) per observation point.</a:t>
             </a:r>
             <a:endParaRPr lang="en-GB" dirty="0"/>
           </a:p>
@@ -832,7 +834,7 @@
             </a:pPr>
             <a:r>
               <a:rPr lang="en-GB"/>
-              <a:t>The strongest engineering point here is that each source cell has a different retarded time, but the implementation avoids a spatial double loop.</a:t>
+              <a:t>The strongest engineering point here is that each source cell has a different retarded time, but the implementation avoids a spatial double loop. Set up the interpolation by noting the retarded time generally falls between stored time samples.</a:t>
             </a:r>
             <a:endParaRPr lang="en-GB" dirty="0"/>
           </a:p>
@@ -6160,8 +6162,8 @@
         </p:nvSpPr>
         <p:spPr>
           <a:xfrm>
-            <a:off x="546100" y="1803400"/>
-            <a:ext cx="3238500" cy="378565"/>
+            <a:off x="546100" y="2200000"/>
+            <a:ext cx="4400000" cy="378565"/>
           </a:xfrm>
           <a:prstGeom prst="rect">
             <a:avLst/>
@@ -6181,7 +6183,7 @@
                 </a:solidFill>
                 <a:latin typeface="Arial" panose="020B0604020202020204" pitchFamily="34" charset="0"/>
               </a:rPr>
-              <a:t>Yaoqi Dong's contribution to the THz emitter simulation project</a:t>
+              <a:t>Yaoqi Dong: turning the team's simulated current density J(r,t) into the radiated far-field THz signal</a:t>
             </a:r>
           </a:p>
         </p:txBody>
@@ -6622,6 +6624,468 @@
 </p:sld>
 </file>
 
+<file path=ppt/slides/slide10.xml><?xml version="1.0" encoding="utf-8"?>
+<p:sld xmlns:a="http://schemas.openxmlformats.org/drawingml/2006/main" xmlns:r="http://schemas.openxmlformats.org/officeDocument/2006/relationships" xmlns:p="http://schemas.openxmlformats.org/presentationml/2006/main">
+  <p:cSld>
+    <p:spTree>
+      <p:nvGrpSpPr>
+        <p:cNvPr id="1" name=""/>
+        <p:cNvGrpSpPr/>
+        <p:nvPr/>
+      </p:nvGrpSpPr>
+      <p:grpSpPr>
+        <a:xfrm>
+          <a:off x="0" y="0"/>
+          <a:ext cx="0" cy="0"/>
+          <a:chOff x="0" y="0"/>
+          <a:chExt cx="0" cy="0"/>
+        </a:xfrm>
+      </p:grpSpPr>
+      <p:sp>
+        <p:nvSpPr>
+          <p:cNvPr id="2" name="Text Placeholder 1"/>
+          <p:cNvSpPr>
+            <a:spLocks noGrp="1"/>
+          </p:cNvSpPr>
+          <p:nvPr>
+            <p:ph type="body" sz="quarter" idx="13"/>
+          </p:nvPr>
+        </p:nvSpPr>
+        <p:spPr>
+          <a:xfrm>
+            <a:off x="635000" y="635000"/>
+            <a:ext cx="6794500" cy="584200"/>
+          </a:xfrm>
+        </p:spPr>
+        <p:txBody>
+          <a:bodyPr>
+            <a:noAutofit/>
+          </a:bodyPr>
+          <a:lstStyle/>
+          <a:p>
+            <a:r>
+              <a:rPr lang="en-GB" sz="1600">
+                <a:solidFill>
+                  <a:srgbClr val="001B3A"/>
+                </a:solidFill>
+                <a:latin typeface="Arial" panose="020B0604020202020204" pitchFamily="34" charset="0"/>
+              </a:rPr>
+              <a:t>Contribution: an end-to-end pipeline from carrier dynamics to validated THz field patterns</a:t>
+            </a:r>
+          </a:p>
+        </p:txBody>
+      </p:sp>
+      <p:cxnSp>
+        <p:nvCxnSpPr>
+          <p:cNvPr id="3" name="Accent Line"/>
+          <p:cNvCxnSpPr/>
+          <p:nvPr/>
+        </p:nvCxnSpPr>
+        <p:spPr>
+          <a:xfrm>
+            <a:off x="635000" y="1295400"/>
+            <a:ext cx="990600" cy="0"/>
+          </a:xfrm>
+          <a:prstGeom prst="line">
+            <a:avLst/>
+          </a:prstGeom>
+          <a:ln w="33020">
+            <a:solidFill>
+              <a:srgbClr val="F6A800"/>
+            </a:solidFill>
+          </a:ln>
+        </p:spPr>
+      </p:cxnSp>
+      <p:sp>
+        <p:nvSpPr>
+          <p:cNvPr id="4" name="Conclusions Card"/>
+          <p:cNvSpPr/>
+          <p:nvPr/>
+        </p:nvSpPr>
+        <p:spPr>
+          <a:xfrm>
+            <a:off x="635000" y="1574800"/>
+            <a:ext cx="3886200" cy="2057400"/>
+          </a:xfrm>
+          <a:prstGeom prst="roundRect">
+            <a:avLst/>
+          </a:prstGeom>
+          <a:solidFill>
+            <a:srgbClr val="F7FAFC"/>
+          </a:solidFill>
+          <a:ln w="9525" cap="flat" cmpd="sng" algn="ctr">
+            <a:solidFill>
+              <a:srgbClr val="D9E2EC"/>
+            </a:solidFill>
+            <a:prstDash val="solid"/>
+            <a:miter lim="800000"/>
+          </a:ln>
+        </p:spPr>
+        <p:txBody>
+          <a:bodyPr lIns="137160" tIns="100584" rIns="137160" bIns="91440" rtlCol="0" anchor="t"/>
+          <a:lstStyle/>
+          <a:p>
+            <a:pPr>
+              <a:spcAft>
+                <a:spcPts val="600"/>
+              </a:spcAft>
+            </a:pPr>
+            <a:r>
+              <a:rPr lang="en-GB" sz="1100" b="1">
+                <a:solidFill>
+                  <a:srgbClr val="005EB8"/>
+                </a:solidFill>
+                <a:latin typeface="Arial" panose="020B0604020202020204" pitchFamily="34" charset="0"/>
+              </a:rPr>
+              <a:t>Conclusions</a:t>
+            </a:r>
+          </a:p>
+          <a:p>
+            <a:pPr>
+              <a:spcAft>
+                <a:spcPts val="500"/>
+              </a:spcAft>
+            </a:pPr>
+            <a:r>
+              <a:rPr lang="en-GB" sz="900">
+                <a:solidFill>
+                  <a:srgbClr val="1F2A35"/>
+                </a:solidFill>
+                <a:latin typeface="Arial" panose="020B0604020202020204" pitchFamily="34" charset="0"/>
+              </a:rPr>
+              <a:t>- Implemented a retarded-potential far-field calculation for full Jx, Jy, Jz histories.</a:t>
+            </a:r>
+          </a:p>
+          <a:p>
+            <a:pPr>
+              <a:spcAft>
+                <a:spcPts val="500"/>
+              </a:spcAft>
+            </a:pPr>
+            <a:r>
+              <a:rPr lang="en-GB" sz="900">
+                <a:solidFill>
+                  <a:srgbClr val="1F2A35"/>
+                </a:solidFill>
+                <a:latin typeface="Arial" panose="020B0604020202020204" pitchFamily="34" charset="0"/>
+              </a:rPr>
+              <a:t>- Coupled carrier diffusion and built-in-field dynamics to time-domain THz waveforms.</a:t>
+            </a:r>
+          </a:p>
+          <a:p>
+            <a:pPr>
+              <a:spcAft>
+                <a:spcPts val="500"/>
+              </a:spcAft>
+            </a:pPr>
+            <a:r>
+              <a:rPr lang="en-GB" sz="900">
+                <a:solidFill>
+                  <a:srgbClr val="1F2A35"/>
+                </a:solidFill>
+                <a:latin typeface="Arial" panose="020B0604020202020204" pitchFamily="34" charset="0"/>
+              </a:rPr>
+              <a:t>- Reproduced the angular emission lobe (peak near 25 degrees) reported in the literature.</a:t>
+            </a:r>
+          </a:p>
+        </p:txBody>
+      </p:sp>
+      <p:sp>
+        <p:nvSpPr>
+          <p:cNvPr id="5" name="Future Work Card"/>
+          <p:cNvSpPr/>
+          <p:nvPr/>
+        </p:nvSpPr>
+        <p:spPr>
+          <a:xfrm>
+            <a:off x="4622800" y="1574800"/>
+            <a:ext cx="3886200" cy="2057400"/>
+          </a:xfrm>
+          <a:prstGeom prst="roundRect">
+            <a:avLst/>
+          </a:prstGeom>
+          <a:solidFill>
+            <a:srgbClr val="F7FAFC"/>
+          </a:solidFill>
+          <a:ln w="9525" cap="flat" cmpd="sng" algn="ctr">
+            <a:solidFill>
+              <a:srgbClr val="D9E2EC"/>
+            </a:solidFill>
+            <a:prstDash val="solid"/>
+            <a:miter lim="800000"/>
+          </a:ln>
+        </p:spPr>
+        <p:txBody>
+          <a:bodyPr lIns="137160" tIns="100584" rIns="137160" bIns="91440" rtlCol="0" anchor="t"/>
+          <a:lstStyle/>
+          <a:p>
+            <a:pPr>
+              <a:spcAft>
+                <a:spcPts val="600"/>
+              </a:spcAft>
+            </a:pPr>
+            <a:r>
+              <a:rPr lang="en-GB" sz="1100" b="1">
+                <a:solidFill>
+                  <a:srgbClr val="F6A800"/>
+                </a:solidFill>
+                <a:latin typeface="Arial" panose="020B0604020202020204" pitchFamily="34" charset="0"/>
+              </a:rPr>
+              <a:t>Future work</a:t>
+            </a:r>
+          </a:p>
+          <a:p>
+            <a:pPr>
+              <a:spcAft>
+                <a:spcPts val="500"/>
+              </a:spcAft>
+            </a:pPr>
+            <a:r>
+              <a:rPr lang="en-GB" sz="900">
+                <a:solidFill>
+                  <a:srgbClr val="1F2A35"/>
+                </a:solidFill>
+                <a:latin typeface="Arial" panose="020B0604020202020204" pitchFamily="34" charset="0"/>
+              </a:rPr>
+              <a:t>- Calibrate waveform amplitudes using detector response and collection geometry.</a:t>
+            </a:r>
+          </a:p>
+          <a:p>
+            <a:pPr>
+              <a:spcAft>
+                <a:spcPts val="500"/>
+              </a:spcAft>
+            </a:pPr>
+            <a:r>
+              <a:rPr lang="en-GB" sz="900">
+                <a:solidFill>
+                  <a:srgbClr val="1F2A35"/>
+                </a:solidFill>
+                <a:latin typeface="Arial" panose="020B0604020202020204" pitchFamily="34" charset="0"/>
+              </a:rPr>
+              <a:t>- Run sensitivity studies for beam waist, carrier lifetime, mobility and depletion field.</a:t>
+            </a:r>
+          </a:p>
+          <a:p>
+            <a:pPr>
+              <a:spcAft>
+                <a:spcPts val="500"/>
+              </a:spcAft>
+            </a:pPr>
+            <a:r>
+              <a:rPr lang="en-GB" sz="900">
+                <a:solidFill>
+                  <a:srgbClr val="1F2A35"/>
+                </a:solidFill>
+                <a:latin typeface="Arial" panose="020B0604020202020204" pitchFamily="34" charset="0"/>
+              </a:rPr>
+              <a:t>- Extend to structured metasurfaces and spatially resolved THz field maps.</a:t>
+            </a:r>
+          </a:p>
+        </p:txBody>
+      </p:sp>
+      <p:sp>
+        <p:nvSpPr>
+          <p:cNvPr id="6" name="QA Takeaway"/>
+          <p:cNvSpPr/>
+          <p:nvPr/>
+        </p:nvSpPr>
+        <p:spPr>
+          <a:xfrm>
+            <a:off x="635000" y="3784600"/>
+            <a:ext cx="7874000" cy="762000"/>
+          </a:xfrm>
+          <a:prstGeom prst="roundRect">
+            <a:avLst/>
+          </a:prstGeom>
+          <a:solidFill>
+            <a:srgbClr val="EEF3F8"/>
+          </a:solidFill>
+          <a:ln w="9525" cap="flat" cmpd="sng" algn="ctr">
+            <a:solidFill>
+              <a:srgbClr val="D9E2EC"/>
+            </a:solidFill>
+            <a:prstDash val="solid"/>
+            <a:miter lim="800000"/>
+          </a:ln>
+        </p:spPr>
+        <p:txBody>
+          <a:bodyPr lIns="137160" tIns="45720" rIns="137160" bIns="45720" rtlCol="0" anchor="ctr"/>
+          <a:lstStyle/>
+          <a:p>
+            <a:r>
+              <a:rPr lang="en-GB" sz="950" b="1">
+                <a:solidFill>
+                  <a:srgbClr val="001B3A"/>
+                </a:solidFill>
+                <a:latin typeface="Arial" panose="020B0604020202020204" pitchFamily="34" charset="0"/>
+              </a:rPr>
+              <a:t>Takeaway for Q&amp;A:  </a:t>
+            </a:r>
+            <a:r>
+              <a:rPr lang="en-GB" sz="950">
+                <a:solidFill>
+                  <a:srgbClr val="1F2A35"/>
+                </a:solidFill>
+                <a:latin typeface="Arial" panose="020B0604020202020204" pitchFamily="34" charset="0"/>
+              </a:rPr>
+              <a:t>the key assumption is that normalised angular shape is a valid first validation target for the far-field model.</a:t>
+            </a:r>
+          </a:p>
+        </p:txBody>
+      </p:sp>
+      <p:sp>
+        <p:nvSpPr>
+          <p:cNvPr id="19" name="Footer Cover"/>
+          <p:cNvSpPr/>
+          <p:nvPr/>
+        </p:nvSpPr>
+        <p:spPr>
+          <a:xfrm>
+            <a:off x="0" y="4699000"/>
+            <a:ext cx="9144000" cy="444500"/>
+          </a:xfrm>
+          <a:prstGeom prst="rect">
+            <a:avLst/>
+          </a:prstGeom>
+          <a:solidFill>
+            <a:srgbClr val="FFFFFF"/>
+          </a:solidFill>
+          <a:ln>
+            <a:noFill/>
+          </a:ln>
+        </p:spPr>
+        <p:txBody>
+          <a:bodyPr rtlCol="0" anchor="ctr"/>
+          <a:lstStyle/>
+          <a:p>
+            <a:pPr algn="ctr"/>
+            <a:endParaRPr lang="en-GB"/>
+          </a:p>
+        </p:txBody>
+      </p:sp>
+      <p:cxnSp>
+        <p:nvCxnSpPr>
+          <p:cNvPr id="7" name="Footer Divider"/>
+          <p:cNvCxnSpPr/>
+          <p:nvPr/>
+        </p:nvCxnSpPr>
+        <p:spPr>
+          <a:xfrm>
+            <a:off x="508000" y="4749800"/>
+            <a:ext cx="8128000" cy="0"/>
+          </a:xfrm>
+          <a:prstGeom prst="line">
+            <a:avLst/>
+          </a:prstGeom>
+          <a:ln w="6350">
+            <a:solidFill>
+              <a:srgbClr val="D9E2EC"/>
+            </a:solidFill>
+          </a:ln>
+        </p:spPr>
+      </p:cxnSp>
+      <p:sp>
+        <p:nvSpPr>
+          <p:cNvPr id="8" name="Footer Text"/>
+          <p:cNvSpPr txBox="1"/>
+          <p:nvPr/>
+        </p:nvSpPr>
+        <p:spPr>
+          <a:xfrm>
+            <a:off x="533400" y="4851400"/>
+            <a:ext cx="7112000" cy="96950"/>
+          </a:xfrm>
+          <a:prstGeom prst="rect">
+            <a:avLst/>
+          </a:prstGeom>
+          <a:noFill/>
+        </p:spPr>
+        <p:txBody>
+          <a:bodyPr vert="horz" wrap="square" lIns="0" tIns="0" rIns="0" bIns="0" rtlCol="0">
+            <a:spAutoFit/>
+          </a:bodyPr>
+          <a:lstStyle/>
+          <a:p>
+            <a:r>
+              <a:rPr lang="en-GB" sz="630">
+                <a:solidFill>
+                  <a:srgbClr val="5B6770"/>
+                </a:solidFill>
+                <a:latin typeface="Arial" panose="020B0604020202020204" pitchFamily="34" charset="0"/>
+              </a:rPr>
+              <a:t>Summary of contributions prepared against the ELEC0118 final project presentation rubric.</a:t>
+            </a:r>
+          </a:p>
+        </p:txBody>
+      </p:sp>
+      <p:sp>
+        <p:nvSpPr>
+          <p:cNvPr id="9" name="Page Number"/>
+          <p:cNvSpPr txBox="1"/>
+          <p:nvPr/>
+        </p:nvSpPr>
+        <p:spPr>
+          <a:xfrm>
+            <a:off x="8280400" y="4813300"/>
+            <a:ext cx="355600" cy="123111"/>
+          </a:xfrm>
+          <a:prstGeom prst="rect">
+            <a:avLst/>
+          </a:prstGeom>
+          <a:noFill/>
+        </p:spPr>
+        <p:txBody>
+          <a:bodyPr vert="horz" wrap="square" lIns="0" tIns="0" rIns="0" bIns="0" rtlCol="0">
+            <a:spAutoFit/>
+          </a:bodyPr>
+          <a:lstStyle/>
+          <a:p>
+            <a:pPr algn="r"/>
+            <a:r>
+              <a:rPr lang="en-GB" sz="800" b="1">
+                <a:solidFill>
+                  <a:srgbClr val="005EB8"/>
+                </a:solidFill>
+                <a:latin typeface="Arial" panose="020B0604020202020204" pitchFamily="34" charset="0"/>
+              </a:rPr>
+              <a:t>10</a:t>
+            </a:r>
+          </a:p>
+        </p:txBody>
+      </p:sp>
+      <p:sp>
+        <p:nvSpPr>
+          <p:cNvPr id="20" name="Slide Number Placeholder"/>
+          <p:cNvSpPr>
+            <a:spLocks noGrp="1"/>
+          </p:cNvSpPr>
+          <p:nvPr>
+            <p:ph type="sldNum" sz="quarter" idx="4294967295"/>
+          </p:nvPr>
+        </p:nvSpPr>
+        <p:spPr>
+          <a:xfrm>
+            <a:off x="7686675" y="4774168"/>
+            <a:ext cx="1143000" cy="234950"/>
+          </a:xfrm>
+        </p:spPr>
+        <p:txBody>
+          <a:bodyPr/>
+          <a:lstStyle/>
+          <a:p>
+            <a:endParaRPr lang="en-GB"/>
+          </a:p>
+        </p:txBody>
+      </p:sp>
+    </p:spTree>
+  </p:cSld>
+  <p:clrMapOvr>
+    <a:masterClrMapping/>
+  </p:clrMapOvr>
+</p:sld>
+</file>
+
 <file path=ppt/slides/slide2.xml><?xml version="1.0" encoding="utf-8"?>
 <p:sld xmlns:a="http://schemas.openxmlformats.org/drawingml/2006/main" xmlns:r="http://schemas.openxmlformats.org/officeDocument/2006/relationships" xmlns:p="http://schemas.openxmlformats.org/presentationml/2006/main">
   <p:cSld>
@@ -7098,22 +7562,6 @@
                 <a:latin typeface="Arial" panose="020B0604020202020204" pitchFamily="34" charset="0"/>
               </a:rPr>
               <a:t>- The double cross product extracts the transverse component that can propagate.</a:t>
-            </a:r>
-          </a:p>
-          <a:p>
-            <a:pPr>
-              <a:spcAft>
-                <a:spcPts val="400"/>
-              </a:spcAft>
-            </a:pPr>
-            <a:r>
-              <a:rPr lang="en-GB" sz="1240">
-                <a:solidFill>
-                  <a:srgbClr val="1F2A35"/>
-                </a:solidFill>
-                <a:latin typeface="Arial" panose="020B0604020202020204" pitchFamily="34" charset="0"/>
-              </a:rPr>
-              <a:t>- A steady current does not radiate; the emitted field follows dJ/dt.</a:t>
             </a:r>
           </a:p>
         </p:txBody>
@@ -8082,22 +8530,6 @@
               <a:t>- R, Rhat and retarded indices are computed as matrices for all source cells.</a:t>
             </a:r>
           </a:p>
-          <a:p>
-            <a:pPr>
-              <a:spcAft>
-                <a:spcPts val="400"/>
-              </a:spcAft>
-            </a:pPr>
-            <a:r>
-              <a:rPr lang="en-GB" sz="1080">
-                <a:solidFill>
-                  <a:srgbClr val="1F2A35"/>
-                </a:solidFill>
-                <a:latin typeface="Arial" panose="020B0604020202020204" pitchFamily="34" charset="0"/>
-              </a:rPr>
-              <a:t>- Complexity is O(Nx Ny Nt) per observation point.</a:t>
-            </a:r>
-          </a:p>
         </p:txBody>
       </p:sp>
       <p:sp>
@@ -8300,11 +8732,11 @@
   <p:clrMapOvr>
     <a:masterClrMapping/>
   </p:clrMapOvr>
-  <mc:AlternateContent xmlns:mc="http://schemas.openxmlformats.org/markup-compatibility/2006">
-    <mc:Choice xmlns:p14="http://schemas.microsoft.com/office/powerpoint/2010/main" Requires="p14">
+  <mc:AlternateContent xmlns:mc="http://schemas.openxmlformats.org/markup-compatibility/2006" xmlns:p14="http://schemas.microsoft.com/office/powerpoint/2010/main">
+    <mc:Choice Requires="p14">
       <p:transition spd="slow" p14:dur="2000" advTm="5000"/>
     </mc:Choice>
-    <mc:Fallback>
+    <mc:Fallback xmlns="">
       <p:transition spd="slow" advTm="5000"/>
     </mc:Fallback>
   </mc:AlternateContent>
@@ -8790,22 +9222,6 @@
                 </a:solidFill>
                 <a:latin typeface="Arial" panose="020B0604020202020204" pitchFamily="34" charset="0"/>
               </a:rPr>
-              <a:t>- Retarded time generally falls between stored time samples.</a:t>
-            </a:r>
-          </a:p>
-          <a:p>
-            <a:pPr>
-              <a:spcAft>
-                <a:spcPts val="400"/>
-              </a:spcAft>
-            </a:pPr>
-            <a:r>
-              <a:rPr lang="en-GB" sz="1070">
-                <a:solidFill>
-                  <a:srgbClr val="1F2A35"/>
-                </a:solidFill>
-                <a:latin typeface="Arial" panose="020B0604020202020204" pitchFamily="34" charset="0"/>
-              </a:rPr>
               <a:t>- The code builds linear indices with grid_y, grid_x and k1_safe.</a:t>
             </a:r>
           </a:p>
@@ -9043,11 +9459,11 @@
   <p:clrMapOvr>
     <a:masterClrMapping/>
   </p:clrMapOvr>
-  <mc:AlternateContent xmlns:mc="http://schemas.openxmlformats.org/markup-compatibility/2006">
-    <mc:Choice xmlns:p14="http://schemas.microsoft.com/office/powerpoint/2010/main" Requires="p14">
+  <mc:AlternateContent xmlns:mc="http://schemas.openxmlformats.org/markup-compatibility/2006" xmlns:p14="http://schemas.microsoft.com/office/powerpoint/2010/main">
+    <mc:Choice Requires="p14">
       <p:transition spd="slow" p14:dur="2000" advTm="5000"/>
     </mc:Choice>
-    <mc:Fallback>
+    <mc:Fallback xmlns="">
       <p:transition spd="slow" advTm="5000"/>
     </mc:Fallback>
   </mc:AlternateContent>
@@ -9829,11 +10245,11 @@
   <p:clrMapOvr>
     <a:masterClrMapping/>
   </p:clrMapOvr>
-  <mc:AlternateContent xmlns:mc="http://schemas.openxmlformats.org/markup-compatibility/2006">
-    <mc:Choice xmlns:p14="http://schemas.microsoft.com/office/powerpoint/2010/main" Requires="p14">
+  <mc:AlternateContent xmlns:mc="http://schemas.openxmlformats.org/markup-compatibility/2006" xmlns:p14="http://schemas.microsoft.com/office/powerpoint/2010/main">
+    <mc:Choice Requires="p14">
       <p:transition spd="slow" p14:dur="2000" advTm="5000"/>
     </mc:Choice>
-    <mc:Fallback>
+    <mc:Fallback xmlns="">
       <p:transition spd="slow" advTm="5000"/>
     </mc:Fallback>
   </mc:AlternateContent>
@@ -10621,11 +11037,11 @@
   <p:clrMapOvr>
     <a:masterClrMapping/>
   </p:clrMapOvr>
-  <mc:AlternateContent xmlns:mc="http://schemas.openxmlformats.org/markup-compatibility/2006">
-    <mc:Choice xmlns:p14="http://schemas.microsoft.com/office/powerpoint/2010/main" Requires="p14">
+  <mc:AlternateContent xmlns:mc="http://schemas.openxmlformats.org/markup-compatibility/2006" xmlns:p14="http://schemas.microsoft.com/office/powerpoint/2010/main">
+    <mc:Choice Requires="p14">
       <p:transition spd="slow" p14:dur="2000" advTm="5000"/>
     </mc:Choice>
-    <mc:Fallback>
+    <mc:Fallback xmlns="">
       <p:transition spd="slow" advTm="5000"/>
     </mc:Fallback>
   </mc:AlternateContent>
@@ -11489,11 +11905,11 @@
   <p:clrMapOvr>
     <a:masterClrMapping/>
   </p:clrMapOvr>
-  <mc:AlternateContent xmlns:mc="http://schemas.openxmlformats.org/markup-compatibility/2006">
-    <mc:Choice xmlns:p14="http://schemas.microsoft.com/office/powerpoint/2010/main" Requires="p14">
+  <mc:AlternateContent xmlns:mc="http://schemas.openxmlformats.org/markup-compatibility/2006" xmlns:p14="http://schemas.microsoft.com/office/powerpoint/2010/main">
+    <mc:Choice Requires="p14">
       <p:transition spd="slow" p14:dur="2000" advTm="5000"/>
     </mc:Choice>
-    <mc:Fallback>
+    <mc:Fallback xmlns="">
       <p:transition spd="slow" advTm="5000"/>
     </mc:Fallback>
   </mc:AlternateContent>
@@ -12432,14 +12848,476 @@
   <p:clrMapOvr>
     <a:masterClrMapping/>
   </p:clrMapOvr>
-  <mc:AlternateContent xmlns:mc="http://schemas.openxmlformats.org/markup-compatibility/2006">
-    <mc:Choice xmlns:p14="http://schemas.microsoft.com/office/powerpoint/2010/main" Requires="p14">
+  <mc:AlternateContent xmlns:mc="http://schemas.openxmlformats.org/markup-compatibility/2006" xmlns:p14="http://schemas.microsoft.com/office/powerpoint/2010/main">
+    <mc:Choice Requires="p14">
       <p:transition spd="slow" p14:dur="2000" advTm="5000"/>
     </mc:Choice>
-    <mc:Fallback>
+    <mc:Fallback xmlns="">
       <p:transition spd="slow" advTm="5000"/>
     </mc:Fallback>
   </mc:AlternateContent>
+</p:sld>
+</file>
+
+<file path=ppt/slides/slide9.xml><?xml version="1.0" encoding="utf-8"?>
+<p:sld xmlns:a="http://schemas.openxmlformats.org/drawingml/2006/main" xmlns:r="http://schemas.openxmlformats.org/officeDocument/2006/relationships" xmlns:p="http://schemas.openxmlformats.org/presentationml/2006/main">
+  <p:cSld>
+    <p:spTree>
+      <p:nvGrpSpPr>
+        <p:cNvPr id="1" name=""/>
+        <p:cNvGrpSpPr/>
+        <p:nvPr/>
+      </p:nvGrpSpPr>
+      <p:grpSpPr>
+        <a:xfrm>
+          <a:off x="0" y="0"/>
+          <a:ext cx="0" cy="0"/>
+          <a:chOff x="0" y="0"/>
+          <a:chExt cx="0" cy="0"/>
+        </a:xfrm>
+      </p:grpSpPr>
+      <p:sp>
+        <p:nvSpPr>
+          <p:cNvPr id="2" name="Text Placeholder 1"/>
+          <p:cNvSpPr>
+            <a:spLocks noGrp="1"/>
+          </p:cNvSpPr>
+          <p:nvPr>
+            <p:ph type="body" sz="quarter" idx="13"/>
+          </p:nvPr>
+        </p:nvSpPr>
+        <p:spPr>
+          <a:xfrm>
+            <a:off x="635000" y="635000"/>
+            <a:ext cx="6794500" cy="584200"/>
+          </a:xfrm>
+        </p:spPr>
+        <p:txBody>
+          <a:bodyPr>
+            <a:noAutofit/>
+          </a:bodyPr>
+          <a:lstStyle/>
+          <a:p>
+            <a:r>
+              <a:rPr lang="en-GB" sz="1600">
+                <a:solidFill>
+                  <a:srgbClr val="001B3A"/>
+                </a:solidFill>
+                <a:latin typeface="Arial" panose="020B0604020202020204" pitchFamily="34" charset="0"/>
+              </a:rPr>
+              <a:t>The model is validated for angular shape rather than absolute THz power</a:t>
+            </a:r>
+          </a:p>
+        </p:txBody>
+      </p:sp>
+      <p:cxnSp>
+        <p:nvCxnSpPr>
+          <p:cNvPr id="3" name="Accent Line"/>
+          <p:cNvCxnSpPr/>
+          <p:nvPr/>
+        </p:nvCxnSpPr>
+        <p:spPr>
+          <a:xfrm>
+            <a:off x="635000" y="1295400"/>
+            <a:ext cx="990600" cy="0"/>
+          </a:xfrm>
+          <a:prstGeom prst="line">
+            <a:avLst/>
+          </a:prstGeom>
+          <a:ln w="33020">
+            <a:solidFill>
+              <a:srgbClr val="F6A800"/>
+            </a:solidFill>
+          </a:ln>
+        </p:spPr>
+      </p:cxnSp>
+      <p:sp>
+        <p:nvSpPr>
+          <p:cNvPr id="4" name="Strengths Card"/>
+          <p:cNvSpPr/>
+          <p:nvPr/>
+        </p:nvSpPr>
+        <p:spPr>
+          <a:xfrm>
+            <a:off x="635000" y="1574800"/>
+            <a:ext cx="3886200" cy="2057400"/>
+          </a:xfrm>
+          <a:prstGeom prst="roundRect">
+            <a:avLst/>
+          </a:prstGeom>
+          <a:solidFill>
+            <a:srgbClr val="F7FAFC"/>
+          </a:solidFill>
+          <a:ln w="9525" cap="flat" cmpd="sng" algn="ctr">
+            <a:solidFill>
+              <a:srgbClr val="D9E2EC"/>
+            </a:solidFill>
+            <a:prstDash val="solid"/>
+            <a:miter lim="800000"/>
+          </a:ln>
+        </p:spPr>
+        <p:txBody>
+          <a:bodyPr lIns="137160" tIns="100584" rIns="137160" bIns="91440" rtlCol="0" anchor="t"/>
+          <a:lstStyle/>
+          <a:p>
+            <a:pPr>
+              <a:spcAft>
+                <a:spcPts val="600"/>
+              </a:spcAft>
+            </a:pPr>
+            <a:r>
+              <a:rPr lang="en-GB" sz="1100" b="1">
+                <a:solidFill>
+                  <a:srgbClr val="005EB8"/>
+                </a:solidFill>
+                <a:latin typeface="Arial" panose="020B0604020202020204" pitchFamily="34" charset="0"/>
+              </a:rPr>
+              <a:t>Strengths</a:t>
+            </a:r>
+          </a:p>
+          <a:p>
+            <a:pPr>
+              <a:spcAft>
+                <a:spcPts val="500"/>
+              </a:spcAft>
+            </a:pPr>
+            <a:r>
+              <a:rPr lang="en-GB" sz="900">
+                <a:solidFill>
+                  <a:srgbClr val="1F2A35"/>
+                </a:solidFill>
+                <a:latin typeface="Arial" panose="020B0604020202020204" pitchFamily="34" charset="0"/>
+              </a:rPr>
+              <a:t>- Causal propagation is preserved through retarded-time interpolation.</a:t>
+            </a:r>
+          </a:p>
+          <a:p>
+            <a:pPr>
+              <a:spcAft>
+                <a:spcPts val="500"/>
+              </a:spcAft>
+            </a:pPr>
+            <a:r>
+              <a:rPr lang="en-GB" sz="900">
+                <a:solidFill>
+                  <a:srgbClr val="1F2A35"/>
+                </a:solidFill>
+                <a:latin typeface="Arial" panose="020B0604020202020204" pitchFamily="34" charset="0"/>
+              </a:rPr>
+              <a:t>- Vector field output makes polarisation and viewing angle part of the result.</a:t>
+            </a:r>
+          </a:p>
+          <a:p>
+            <a:pPr>
+              <a:spcAft>
+                <a:spcPts val="500"/>
+              </a:spcAft>
+            </a:pPr>
+            <a:r>
+              <a:rPr lang="en-GB" sz="900">
+                <a:solidFill>
+                  <a:srgbClr val="1F2A35"/>
+                </a:solidFill>
+                <a:latin typeface="Arial" panose="020B0604020202020204" pitchFamily="34" charset="0"/>
+              </a:rPr>
+              <a:t>- Physical mechanisms are separated for controlled comparison of source currents.</a:t>
+            </a:r>
+          </a:p>
+        </p:txBody>
+      </p:sp>
+      <p:sp>
+        <p:nvSpPr>
+          <p:cNvPr id="5" name="Limitations Card"/>
+          <p:cNvSpPr/>
+          <p:nvPr/>
+        </p:nvSpPr>
+        <p:spPr>
+          <a:xfrm>
+            <a:off x="4622800" y="1574800"/>
+            <a:ext cx="3886200" cy="2057400"/>
+          </a:xfrm>
+          <a:prstGeom prst="roundRect">
+            <a:avLst/>
+          </a:prstGeom>
+          <a:solidFill>
+            <a:srgbClr val="F7FAFC"/>
+          </a:solidFill>
+          <a:ln w="9525" cap="flat" cmpd="sng" algn="ctr">
+            <a:solidFill>
+              <a:srgbClr val="D9E2EC"/>
+            </a:solidFill>
+            <a:prstDash val="solid"/>
+            <a:miter lim="800000"/>
+          </a:ln>
+        </p:spPr>
+        <p:txBody>
+          <a:bodyPr lIns="137160" tIns="100584" rIns="137160" bIns="91440" rtlCol="0" anchor="t"/>
+          <a:lstStyle/>
+          <a:p>
+            <a:pPr>
+              <a:spcAft>
+                <a:spcPts val="600"/>
+              </a:spcAft>
+            </a:pPr>
+            <a:r>
+              <a:rPr lang="en-GB" sz="1100" b="1">
+                <a:solidFill>
+                  <a:srgbClr val="B23A48"/>
+                </a:solidFill>
+                <a:latin typeface="Arial" panose="020B0604020202020204" pitchFamily="34" charset="0"/>
+              </a:rPr>
+              <a:t>Limitations</a:t>
+            </a:r>
+          </a:p>
+          <a:p>
+            <a:pPr>
+              <a:spcAft>
+                <a:spcPts val="500"/>
+              </a:spcAft>
+            </a:pPr>
+            <a:r>
+              <a:rPr lang="en-GB" sz="900">
+                <a:solidFill>
+                  <a:srgbClr val="1F2A35"/>
+                </a:solidFill>
+                <a:latin typeface="Arial" panose="020B0604020202020204" pitchFamily="34" charset="0"/>
+              </a:rPr>
+              <a:t>- Carrier transport is simplified versus full Monte Carlo modelling.</a:t>
+            </a:r>
+          </a:p>
+          <a:p>
+            <a:pPr>
+              <a:spcAft>
+                <a:spcPts val="500"/>
+              </a:spcAft>
+            </a:pPr>
+            <a:r>
+              <a:rPr lang="en-GB" sz="900">
+                <a:solidFill>
+                  <a:srgbClr val="1F2A35"/>
+                </a:solidFill>
+                <a:latin typeface="Arial" panose="020B0604020202020204" pitchFamily="34" charset="0"/>
+              </a:rPr>
+              <a:t>- The far-field approximation drops near-field and detector-response effects.</a:t>
+            </a:r>
+          </a:p>
+          <a:p>
+            <a:pPr>
+              <a:spcAft>
+                <a:spcPts val="500"/>
+              </a:spcAft>
+            </a:pPr>
+            <a:r>
+              <a:rPr lang="en-GB" sz="900">
+                <a:solidFill>
+                  <a:srgbClr val="1F2A35"/>
+                </a:solidFill>
+                <a:latin typeface="Arial" panose="020B0604020202020204" pitchFamily="34" charset="0"/>
+              </a:rPr>
+              <a:t>- Validation uses normalised angular amplitude, not calibrated absolute power.</a:t>
+            </a:r>
+          </a:p>
+        </p:txBody>
+      </p:sp>
+      <p:sp>
+        <p:nvSpPr>
+          <p:cNvPr id="6" name="What This Means"/>
+          <p:cNvSpPr/>
+          <p:nvPr/>
+        </p:nvSpPr>
+        <p:spPr>
+          <a:xfrm>
+            <a:off x="635000" y="3784600"/>
+            <a:ext cx="7874000" cy="762000"/>
+          </a:xfrm>
+          <a:prstGeom prst="roundRect">
+            <a:avLst/>
+          </a:prstGeom>
+          <a:solidFill>
+            <a:srgbClr val="EEF3F8"/>
+          </a:solidFill>
+          <a:ln w="9525" cap="flat" cmpd="sng" algn="ctr">
+            <a:solidFill>
+              <a:srgbClr val="D9E2EC"/>
+            </a:solidFill>
+            <a:prstDash val="solid"/>
+            <a:miter lim="800000"/>
+          </a:ln>
+        </p:spPr>
+        <p:txBody>
+          <a:bodyPr lIns="137160" tIns="45720" rIns="137160" bIns="45720" rtlCol="0" anchor="ctr"/>
+          <a:lstStyle/>
+          <a:p>
+            <a:r>
+              <a:rPr lang="en-GB" sz="950" b="1">
+                <a:solidFill>
+                  <a:srgbClr val="001B3A"/>
+                </a:solidFill>
+                <a:latin typeface="Arial" panose="020B0604020202020204" pitchFamily="34" charset="0"/>
+              </a:rPr>
+              <a:t>What this means:  </a:t>
+            </a:r>
+            <a:r>
+              <a:rPr lang="en-GB" sz="950">
+                <a:solidFill>
+                  <a:srgbClr val="1F2A35"/>
+                </a:solidFill>
+                <a:latin typeface="Arial" panose="020B0604020202020204" pitchFamily="34" charset="0"/>
+              </a:rPr>
+              <a:t>the pipeline is a credible computational framework; the next step is quantitative calibration against measured waveforms and a systematic sensitivity analysis.</a:t>
+            </a:r>
+          </a:p>
+        </p:txBody>
+      </p:sp>
+      <p:sp>
+        <p:nvSpPr>
+          <p:cNvPr id="19" name="Footer Cover"/>
+          <p:cNvSpPr/>
+          <p:nvPr/>
+        </p:nvSpPr>
+        <p:spPr>
+          <a:xfrm>
+            <a:off x="0" y="4699000"/>
+            <a:ext cx="9144000" cy="444500"/>
+          </a:xfrm>
+          <a:prstGeom prst="rect">
+            <a:avLst/>
+          </a:prstGeom>
+          <a:solidFill>
+            <a:srgbClr val="FFFFFF"/>
+          </a:solidFill>
+          <a:ln>
+            <a:noFill/>
+          </a:ln>
+        </p:spPr>
+        <p:txBody>
+          <a:bodyPr rtlCol="0" anchor="ctr"/>
+          <a:lstStyle/>
+          <a:p>
+            <a:pPr algn="ctr"/>
+            <a:endParaRPr lang="en-GB"/>
+          </a:p>
+        </p:txBody>
+      </p:sp>
+      <p:cxnSp>
+        <p:nvCxnSpPr>
+          <p:cNvPr id="7" name="Footer Divider"/>
+          <p:cNvCxnSpPr/>
+          <p:nvPr/>
+        </p:nvCxnSpPr>
+        <p:spPr>
+          <a:xfrm>
+            <a:off x="508000" y="4749800"/>
+            <a:ext cx="8128000" cy="0"/>
+          </a:xfrm>
+          <a:prstGeom prst="line">
+            <a:avLst/>
+          </a:prstGeom>
+          <a:ln w="6350">
+            <a:solidFill>
+              <a:srgbClr val="D9E2EC"/>
+            </a:solidFill>
+          </a:ln>
+        </p:spPr>
+      </p:cxnSp>
+      <p:sp>
+        <p:nvSpPr>
+          <p:cNvPr id="8" name="Footer Text"/>
+          <p:cNvSpPr txBox="1"/>
+          <p:nvPr/>
+        </p:nvSpPr>
+        <p:spPr>
+          <a:xfrm>
+            <a:off x="533400" y="4851400"/>
+            <a:ext cx="7112000" cy="96950"/>
+          </a:xfrm>
+          <a:prstGeom prst="rect">
+            <a:avLst/>
+          </a:prstGeom>
+          <a:noFill/>
+        </p:spPr>
+        <p:txBody>
+          <a:bodyPr vert="horz" wrap="square" lIns="0" tIns="0" rIns="0" bIns="0" rtlCol="0">
+            <a:spAutoFit/>
+          </a:bodyPr>
+          <a:lstStyle/>
+          <a:p>
+            <a:r>
+              <a:rPr lang="en-GB" sz="630">
+                <a:solidFill>
+                  <a:srgbClr val="5B6770"/>
+                </a:solidFill>
+                <a:latin typeface="Arial" panose="020B0604020202020204" pitchFamily="34" charset="0"/>
+              </a:rPr>
+              <a:t>Mark-scheme alignment: critical analysis of results, not only description of generated plots.</a:t>
+            </a:r>
+          </a:p>
+        </p:txBody>
+      </p:sp>
+      <p:sp>
+        <p:nvSpPr>
+          <p:cNvPr id="9" name="Page Number"/>
+          <p:cNvSpPr txBox="1"/>
+          <p:nvPr/>
+        </p:nvSpPr>
+        <p:spPr>
+          <a:xfrm>
+            <a:off x="8280400" y="4813300"/>
+            <a:ext cx="355600" cy="123111"/>
+          </a:xfrm>
+          <a:prstGeom prst="rect">
+            <a:avLst/>
+          </a:prstGeom>
+          <a:noFill/>
+        </p:spPr>
+        <p:txBody>
+          <a:bodyPr vert="horz" wrap="square" lIns="0" tIns="0" rIns="0" bIns="0" rtlCol="0">
+            <a:spAutoFit/>
+          </a:bodyPr>
+          <a:lstStyle/>
+          <a:p>
+            <a:pPr algn="r"/>
+            <a:r>
+              <a:rPr lang="en-GB" sz="800" b="1">
+                <a:solidFill>
+                  <a:srgbClr val="005EB8"/>
+                </a:solidFill>
+                <a:latin typeface="Arial" panose="020B0604020202020204" pitchFamily="34" charset="0"/>
+              </a:rPr>
+              <a:t>09</a:t>
+            </a:r>
+          </a:p>
+        </p:txBody>
+      </p:sp>
+      <p:sp>
+        <p:nvSpPr>
+          <p:cNvPr id="20" name="Slide Number Placeholder"/>
+          <p:cNvSpPr>
+            <a:spLocks noGrp="1"/>
+          </p:cNvSpPr>
+          <p:nvPr>
+            <p:ph type="sldNum" sz="quarter" idx="4294967295"/>
+          </p:nvPr>
+        </p:nvSpPr>
+        <p:spPr>
+          <a:xfrm>
+            <a:off x="7686675" y="4774168"/>
+            <a:ext cx="1143000" cy="234950"/>
+          </a:xfrm>
+        </p:spPr>
+        <p:txBody>
+          <a:bodyPr/>
+          <a:lstStyle/>
+          <a:p>
+            <a:endParaRPr lang="en-GB"/>
+          </a:p>
+        </p:txBody>
+      </p:sp>
+    </p:spTree>
+  </p:cSld>
+  <p:clrMapOvr>
+    <a:masterClrMapping/>
+  </p:clrMapOvr>
 </p:sld>
 </file>
 

</xml_diff>